<commit_message>
fix: update tab title to Chess Game | Adversarial Engine
</commit_message>
<xml_diff>
--- a/Chess_AI_Engine_Final_Presentation.pptx
+++ b/Chess_AI_Engine_Final_Presentation.pptx
@@ -151,7 +151,7 @@
   <pc:docChgLst>
     <pc:chgData name="Nishant Ambaliya" userId="77ce5dc213ff616a" providerId="LiveId" clId="{65E22951-92F9-466A-A1EC-0C7FB1E03D8B}"/>
     <pc:docChg chg="undo custSel modSld modMainMaster">
-      <pc:chgData name="Nishant Ambaliya" userId="77ce5dc213ff616a" providerId="LiveId" clId="{65E22951-92F9-466A-A1EC-0C7FB1E03D8B}" dt="2026-10-28T13:25:44.973" v="259" actId="1037"/>
+      <pc:chgData name="Nishant Ambaliya" userId="77ce5dc213ff616a" providerId="LiveId" clId="{65E22951-92F9-466A-A1EC-0C7FB1E03D8B}" dt="2026-10-28T14:15:28.736" v="267" actId="1037"/>
       <pc:docMkLst>
         <pc:docMk/>
       </pc:docMkLst>
@@ -178,17 +178,25 @@
         </pc:sldMkLst>
       </pc:sldChg>
       <pc:sldChg chg="modSp mod modTransition setBg">
-        <pc:chgData name="Nishant Ambaliya" userId="77ce5dc213ff616a" providerId="LiveId" clId="{65E22951-92F9-466A-A1EC-0C7FB1E03D8B}" dt="2026-10-28T13:23:20.607" v="190" actId="1036"/>
+        <pc:chgData name="Nishant Ambaliya" userId="77ce5dc213ff616a" providerId="LiveId" clId="{65E22951-92F9-466A-A1EC-0C7FB1E03D8B}" dt="2026-10-28T14:15:28.736" v="267" actId="1037"/>
         <pc:sldMkLst>
           <pc:docMk/>
           <pc:sldMk cId="0" sldId="258"/>
         </pc:sldMkLst>
         <pc:spChg chg="mod">
-          <ac:chgData name="Nishant Ambaliya" userId="77ce5dc213ff616a" providerId="LiveId" clId="{65E22951-92F9-466A-A1EC-0C7FB1E03D8B}" dt="2026-10-28T13:23:20.607" v="190" actId="1036"/>
+          <ac:chgData name="Nishant Ambaliya" userId="77ce5dc213ff616a" providerId="LiveId" clId="{65E22951-92F9-466A-A1EC-0C7FB1E03D8B}" dt="2026-10-28T14:15:28.736" v="267" actId="1037"/>
           <ac:spMkLst>
             <pc:docMk/>
             <pc:sldMk cId="0" sldId="258"/>
             <ac:spMk id="2" creationId="{00000000-0000-0000-0000-000000000000}"/>
+          </ac:spMkLst>
+        </pc:spChg>
+        <pc:spChg chg="mod">
+          <ac:chgData name="Nishant Ambaliya" userId="77ce5dc213ff616a" providerId="LiveId" clId="{65E22951-92F9-466A-A1EC-0C7FB1E03D8B}" dt="2026-10-28T14:15:05.058" v="262" actId="1037"/>
+          <ac:spMkLst>
+            <pc:docMk/>
+            <pc:sldMk cId="0" sldId="258"/>
+            <ac:spMk id="3" creationId="{00000000-0000-0000-0000-000000000000}"/>
           </ac:spMkLst>
         </pc:spChg>
         <pc:spChg chg="mod">
@@ -8638,7 +8646,7 @@
         </p:nvSpPr>
         <p:spPr>
           <a:xfrm>
-            <a:off x="16934" y="-16923"/>
+            <a:off x="-8467" y="11"/>
             <a:ext cx="12191695" cy="6858000"/>
           </a:xfrm>
           <a:prstGeom prst="rect">

</xml_diff>